<commit_message>
Fix code review issues and update stale docs
diagram.py:
- Use idiomatic .sum() for bool column instead of == True
- Remove dead y_pos variable
- Fix structural break guard to check min <= year <= max
- Replace hardcoded ylim(60) with data-driven floor

build_ppt.py:
- Remove duplicate pptx.util import
- Fix make_timeline y-axis annotation to use actual data max
- Fix data-driven ylim floor in make_panel2
- Remove inner Pt import alias in divider()
- Reframe Slide 7 from "What's Next" to "What We Built"

CLAUDE.md:
- Update Repository State to reflect code now exists

Co-Authored-By: Claude Sonnet 4.6 <noreply@anthropic.com>
</commit_message>
<xml_diff>
--- a/exoplanet_data_quality_audit.pptx
+++ b/exoplanet_data_quality_audit.pptx
@@ -5201,7 +5201,7 @@
                   <a:srgbClr val="E2E8F0"/>
                 </a:solidFill>
               </a:rPr>
-              <a:t>What's Next</a:t>
+              <a:t>What We Built</a:t>
             </a:r>
           </a:p>
         </p:txBody>
@@ -5304,7 +5304,7 @@
                   <a:srgbClr val="E2E8F0"/>
                 </a:solidFill>
               </a:rPr>
-              <a:t>Compute per-column missingness rates and pl_eqt_computed split</a:t>
+              <a:t>Computed per-column missingness rates and pl_eqt_computed split from 1,173 records</a:t>
             </a:r>
           </a:p>
         </p:txBody>
@@ -5372,7 +5372,7 @@
                   <a:srgbClr val="E2E8F0"/>
                 </a:solidFill>
               </a:rPr>
-              <a:t>Compute per-year completeness for the 4 worst-offender columns</a:t>
+              <a:t>Computed per-year completeness for st_met, pl_orbsmax, and sy_dist</a:t>
             </a:r>
           </a:p>
         </p:txBody>
@@ -5440,7 +5440,7 @@
                   <a:srgbClr val="E2E8F0"/>
                 </a:solidFill>
               </a:rPr>
-              <a:t>Build Panel 1 — horizontal segmented bar chart</a:t>
+              <a:t>Panel 1 — horizontal segmented bar chart (present / computed / missing)</a:t>
             </a:r>
           </a:p>
         </p:txBody>
@@ -5508,7 +5508,7 @@
                   <a:srgbClr val="E2E8F0"/>
                 </a:solidFill>
               </a:rPr>
-              <a:t>Build Panel 2 — line chart with Kepler / TESS annotations</a:t>
+              <a:t>Panel 2 — line chart with Kepler (2009) and TESS (2018) structural break annotations</a:t>
             </a:r>
           </a:p>
         </p:txBody>
@@ -5576,7 +5576,7 @@
                   <a:srgbClr val="E2E8F0"/>
                 </a:solidFill>
               </a:rPr>
-              <a:t>Compose two-panel layout with shared title and legend</a:t>
+              <a:t>7-slide deck documenting the full data quality story for a practitioner audience</a:t>
             </a:r>
           </a:p>
         </p:txBody>
@@ -5610,7 +5610,7 @@
                   <a:srgbClr val="94A3B8"/>
                 </a:solidFill>
               </a:rPr>
-              <a:t>No implementation decisions (library, format, interactivity) are locked until the Plan phase.</a:t>
+              <a:t>All outputs are reproducible: run diagram.py for the PNG, build_ppt.py for this deck.</a:t>
             </a:r>
           </a:p>
         </p:txBody>

</xml_diff>